<commit_message>
Coğrafya: 9. sınıf 1. ünite 2026.10.1 — tarih şeridinin cevapları kutuların içinde
3. hafta bölümüne, eşleştirme slaytlarından sonra dolu tarih şeridi eklendi:
her çağ ayrı slaytta, kitabın şeridindeki sıra ve renkle, cevap metni en az
24 pt (Yakın Çağ iki slayt). 1. ünite 129 → 134 slayt; çalışma kâğıdı
değişmedi. Yalnız 1. ünite yeniden üretildi (kısmi yayın); 2-4. ünitelerin
dosyaları bayt bayt aynı, kayıtları kendi sürümünü (2026.10) taşır. Ünite
sayfası artık ünitenin kendi sürüm ve tarihini gösterir.

Co-Authored-By: Claude Opus 5.5 <noreply@anthropic.com>
</commit_message>
<xml_diff>
--- a/public/cografya/9-sinif/unite-1/GNL-COG9-SN-U1_Hafta-1_Cografya_Biliminin_Konusu_ve_Bolumleri_v1.0.pptx
+++ b/public/cografya/9-sinif/unite-1/GNL-COG9-SN-U1_Hafta-1_Cografya_Biliminin_Konusu_ve_Bolumleri_v1.0.pptx
@@ -8584,7 +8584,7 @@
                 </a:solidFill>
                 <a:latin typeface="Calibri"/>
               </a:rPr>
-              <a:t>10 / 129</a:t>
+              <a:t>10 / 134</a:t>
             </a:r>
           </a:p>
         </p:txBody>
@@ -9963,7 +9963,7 @@
                 </a:solidFill>
                 <a:latin typeface="Calibri"/>
               </a:rPr>
-              <a:t>11 / 129</a:t>
+              <a:t>11 / 134</a:t>
             </a:r>
           </a:p>
         </p:txBody>
@@ -11238,7 +11238,7 @@
                 </a:solidFill>
                 <a:latin typeface="Calibri"/>
               </a:rPr>
-              <a:t>12 / 129</a:t>
+              <a:t>12 / 134</a:t>
             </a:r>
           </a:p>
         </p:txBody>
@@ -12718,7 +12718,7 @@
                 </a:solidFill>
                 <a:latin typeface="Calibri"/>
               </a:rPr>
-              <a:t>13 / 129</a:t>
+              <a:t>13 / 134</a:t>
             </a:r>
           </a:p>
         </p:txBody>
@@ -13301,7 +13301,7 @@
                 </a:solidFill>
                 <a:latin typeface="Calibri"/>
               </a:rPr>
-              <a:t>14 / 129</a:t>
+              <a:t>14 / 134</a:t>
             </a:r>
           </a:p>
         </p:txBody>
@@ -14261,7 +14261,7 @@
                 </a:solidFill>
                 <a:latin typeface="Calibri"/>
               </a:rPr>
-              <a:t>15 / 129</a:t>
+              <a:t>15 / 134</a:t>
             </a:r>
           </a:p>
         </p:txBody>
@@ -15271,7 +15271,7 @@
                 </a:solidFill>
                 <a:latin typeface="Calibri"/>
               </a:rPr>
-              <a:t>16 / 129</a:t>
+              <a:t>16 / 134</a:t>
             </a:r>
           </a:p>
         </p:txBody>
@@ -16107,7 +16107,7 @@
                 </a:solidFill>
                 <a:latin typeface="Calibri"/>
               </a:rPr>
-              <a:t>17 / 129</a:t>
+              <a:t>17 / 134</a:t>
             </a:r>
           </a:p>
         </p:txBody>
@@ -16940,7 +16940,7 @@
                 </a:solidFill>
                 <a:latin typeface="Calibri"/>
               </a:rPr>
-              <a:t>18 / 129</a:t>
+              <a:t>18 / 134</a:t>
             </a:r>
           </a:p>
         </p:txBody>
@@ -17716,7 +17716,7 @@
                 </a:solidFill>
                 <a:latin typeface="Calibri"/>
               </a:rPr>
-              <a:t>19 / 129</a:t>
+              <a:t>19 / 134</a:t>
             </a:r>
           </a:p>
         </p:txBody>
@@ -18823,7 +18823,7 @@
                 </a:solidFill>
                 <a:latin typeface="Calibri"/>
               </a:rPr>
-              <a:t>2 / 129</a:t>
+              <a:t>2 / 134</a:t>
             </a:r>
           </a:p>
         </p:txBody>
@@ -19432,7 +19432,7 @@
                 </a:solidFill>
                 <a:latin typeface="Calibri"/>
               </a:rPr>
-              <a:t>20 / 129</a:t>
+              <a:t>20 / 134</a:t>
             </a:r>
           </a:p>
         </p:txBody>
@@ -20392,7 +20392,7 @@
                 </a:solidFill>
                 <a:latin typeface="Calibri"/>
               </a:rPr>
-              <a:t>21 / 129</a:t>
+              <a:t>21 / 134</a:t>
             </a:r>
           </a:p>
         </p:txBody>
@@ -21402,7 +21402,7 @@
                 </a:solidFill>
                 <a:latin typeface="Calibri"/>
               </a:rPr>
-              <a:t>22 / 129</a:t>
+              <a:t>22 / 134</a:t>
             </a:r>
           </a:p>
         </p:txBody>
@@ -22590,7 +22590,7 @@
                 </a:solidFill>
                 <a:latin typeface="Calibri"/>
               </a:rPr>
-              <a:t>23 / 129</a:t>
+              <a:t>23 / 134</a:t>
             </a:r>
           </a:p>
         </p:txBody>
@@ -23225,7 +23225,7 @@
                 </a:solidFill>
                 <a:latin typeface="Calibri"/>
               </a:rPr>
-              <a:t>24 / 129</a:t>
+              <a:t>24 / 134</a:t>
             </a:r>
           </a:p>
         </p:txBody>
@@ -24361,7 +24361,7 @@
                 </a:solidFill>
                 <a:latin typeface="Calibri"/>
               </a:rPr>
-              <a:t>25 / 129</a:t>
+              <a:t>25 / 134</a:t>
             </a:r>
           </a:p>
         </p:txBody>
@@ -25464,7 +25464,7 @@
                 </a:solidFill>
                 <a:latin typeface="Calibri"/>
               </a:rPr>
-              <a:t>26 / 129</a:t>
+              <a:t>26 / 134</a:t>
             </a:r>
           </a:p>
         </p:txBody>
@@ -26948,7 +26948,7 @@
                 </a:solidFill>
                 <a:latin typeface="Calibri"/>
               </a:rPr>
-              <a:t>27 / 129</a:t>
+              <a:t>27 / 134</a:t>
             </a:r>
           </a:p>
         </p:txBody>
@@ -28069,7 +28069,7 @@
                 </a:solidFill>
                 <a:latin typeface="Calibri"/>
               </a:rPr>
-              <a:t>28 / 129</a:t>
+              <a:t>28 / 134</a:t>
             </a:r>
           </a:p>
         </p:txBody>
@@ -29637,7 +29637,7 @@
                 </a:solidFill>
                 <a:latin typeface="Calibri"/>
               </a:rPr>
-              <a:t>29 / 129</a:t>
+              <a:t>29 / 134</a:t>
             </a:r>
           </a:p>
         </p:txBody>
@@ -30839,7 +30839,7 @@
                 </a:solidFill>
                 <a:latin typeface="Calibri"/>
               </a:rPr>
-              <a:t>3 / 129</a:t>
+              <a:t>3 / 134</a:t>
             </a:r>
           </a:p>
         </p:txBody>
@@ -31897,7 +31897,7 @@
                 </a:solidFill>
                 <a:latin typeface="Calibri"/>
               </a:rPr>
-              <a:t>30 / 129</a:t>
+              <a:t>30 / 134</a:t>
             </a:r>
           </a:p>
         </p:txBody>
@@ -33269,7 +33269,7 @@
                 </a:solidFill>
                 <a:latin typeface="Calibri"/>
               </a:rPr>
-              <a:t>31 / 129</a:t>
+              <a:t>31 / 134</a:t>
             </a:r>
           </a:p>
         </p:txBody>
@@ -34229,7 +34229,7 @@
                 </a:solidFill>
                 <a:latin typeface="Calibri"/>
               </a:rPr>
-              <a:t>32 / 129</a:t>
+              <a:t>32 / 134</a:t>
             </a:r>
           </a:p>
         </p:txBody>
@@ -35239,7 +35239,7 @@
                 </a:solidFill>
                 <a:latin typeface="Calibri"/>
               </a:rPr>
-              <a:t>33 / 129</a:t>
+              <a:t>33 / 134</a:t>
             </a:r>
           </a:p>
         </p:txBody>
@@ -36171,7 +36171,7 @@
                 </a:solidFill>
                 <a:latin typeface="Calibri"/>
               </a:rPr>
-              <a:t>34 / 129</a:t>
+              <a:t>34 / 134</a:t>
             </a:r>
           </a:p>
         </p:txBody>
@@ -37053,7 +37053,7 @@
                 </a:solidFill>
                 <a:latin typeface="Calibri"/>
               </a:rPr>
-              <a:t>35 / 129</a:t>
+              <a:t>35 / 134</a:t>
             </a:r>
           </a:p>
         </p:txBody>
@@ -38013,7 +38013,7 @@
                 </a:solidFill>
                 <a:latin typeface="Calibri"/>
               </a:rPr>
-              <a:t>36 / 129</a:t>
+              <a:t>36 / 134</a:t>
             </a:r>
           </a:p>
         </p:txBody>
@@ -39023,7 +39023,7 @@
                 </a:solidFill>
                 <a:latin typeface="Calibri"/>
               </a:rPr>
-              <a:t>37 / 129</a:t>
+              <a:t>37 / 134</a:t>
             </a:r>
           </a:p>
         </p:txBody>
@@ -40685,7 +40685,7 @@
                 </a:solidFill>
                 <a:latin typeface="Calibri"/>
               </a:rPr>
-              <a:t>38 / 129</a:t>
+              <a:t>38 / 134</a:t>
             </a:r>
           </a:p>
         </p:txBody>
@@ -42767,7 +42767,7 @@
                 </a:solidFill>
                 <a:latin typeface="Calibri"/>
               </a:rPr>
-              <a:t>39 / 129</a:t>
+              <a:t>39 / 134</a:t>
             </a:r>
           </a:p>
         </p:txBody>
@@ -43891,7 +43891,7 @@
                 </a:solidFill>
                 <a:latin typeface="Calibri"/>
               </a:rPr>
-              <a:t>4 / 129</a:t>
+              <a:t>4 / 134</a:t>
             </a:r>
           </a:p>
         </p:txBody>
@@ -44567,7 +44567,7 @@
                 </a:solidFill>
                 <a:latin typeface="Calibri"/>
               </a:rPr>
-              <a:t>40 / 129</a:t>
+              <a:t>40 / 134</a:t>
             </a:r>
           </a:p>
         </p:txBody>
@@ -45587,7 +45587,7 @@
                 </a:solidFill>
                 <a:latin typeface="Calibri"/>
               </a:rPr>
-              <a:t>41 / 129</a:t>
+              <a:t>41 / 134</a:t>
             </a:r>
           </a:p>
         </p:txBody>
@@ -46239,7 +46239,7 @@
                 </a:solidFill>
                 <a:latin typeface="Calibri"/>
               </a:rPr>
-              <a:t>42 / 129</a:t>
+              <a:t>42 / 134</a:t>
             </a:r>
           </a:p>
         </p:txBody>
@@ -47043,7 +47043,7 @@
                 </a:solidFill>
                 <a:latin typeface="Calibri"/>
               </a:rPr>
-              <a:t>43 / 129</a:t>
+              <a:t>43 / 134</a:t>
             </a:r>
           </a:p>
         </p:txBody>
@@ -47488,7 +47488,7 @@
                 </a:solidFill>
                 <a:latin typeface="Calibri"/>
               </a:rPr>
-              <a:t>okulapp.org/cografya · sürüm 2026.10</a:t>
+              <a:t>okulapp.org/cografya · sürüm 2026.10.1</a:t>
             </a:r>
           </a:p>
         </p:txBody>
@@ -48051,7 +48051,7 @@
                 </a:solidFill>
                 <a:latin typeface="Calibri"/>
               </a:rPr>
-              <a:t>5 / 129</a:t>
+              <a:t>5 / 134</a:t>
             </a:r>
           </a:p>
         </p:txBody>
@@ -49022,7 +49022,7 @@
                 </a:solidFill>
                 <a:latin typeface="Calibri"/>
               </a:rPr>
-              <a:t>6 / 129</a:t>
+              <a:t>6 / 134</a:t>
             </a:r>
           </a:p>
         </p:txBody>
@@ -50249,7 +50249,7 @@
                 </a:solidFill>
                 <a:latin typeface="Calibri"/>
               </a:rPr>
-              <a:t>7 / 129</a:t>
+              <a:t>7 / 134</a:t>
             </a:r>
           </a:p>
         </p:txBody>
@@ -51171,7 +51171,7 @@
                 </a:solidFill>
                 <a:latin typeface="Calibri"/>
               </a:rPr>
-              <a:t>8 / 129</a:t>
+              <a:t>8 / 134</a:t>
             </a:r>
           </a:p>
         </p:txBody>
@@ -52191,7 +52191,7 @@
                 </a:solidFill>
                 <a:latin typeface="Calibri"/>
               </a:rPr>
-              <a:t>9 / 129</a:t>
+              <a:t>9 / 134</a:t>
             </a:r>
           </a:p>
         </p:txBody>

</xml_diff>